<commit_message>
Default on-device Gemma to enabled, fix Sarvam TTS to bulbul:v3, and carry forward in-flight feature work
The on-device model toggle started off every launch by design, which left a
correctly-installed model idle behind a switch nobody flipped; verified
end-to-end on an iQOO I2501 that the default-on flip plus swapping to the
GPU/CPU-compatible Gemma build gets drafting warm on GPU. Sarvam's
text-to-speech default (bulbul:v2, speaker "anushka") doesn't carry over to
bulbul:v3's speaker roster, so both were updated together. Also includes
recurring-reminder adapter/trigger wiring, shopping-list grammar, missed-call
and recurrence-interval signal kits, briefing narration, and doc/deck updates
accumulated on this branch.
</commit_message>
<xml_diff>
--- a/docs/Cues_HyperDeck_8_Page.pptx
+++ b/docs/Cues_HyperDeck_8_Page.pptx
@@ -2,20 +2,20 @@
 <file path=ppt/presentation.xml><?xml version="1.0" encoding="utf-8"?>
 <p:presentation xmlns:p="http://schemas.openxmlformats.org/presentationml/2006/main">
   <p:sldMasterIdLst>
-    <p:sldMasterId xmlns:r="http://schemas.openxmlformats.org/officeDocument/2006/relationships" id="2147483648" r:id="Raaa1a56087cd4468"/>
+    <p:sldMasterId xmlns:r="http://schemas.openxmlformats.org/officeDocument/2006/relationships" id="2147483648" r:id="Re055d7630940483c"/>
   </p:sldMasterIdLst>
   <p:notesMasterIdLst>
-    <p:notesMasterId xmlns:r="http://schemas.openxmlformats.org/officeDocument/2006/relationships" r:id="Rdc87b7f3a4324a96"/>
+    <p:notesMasterId xmlns:r="http://schemas.openxmlformats.org/officeDocument/2006/relationships" r:id="R95279ba974ed48b6"/>
   </p:notesMasterIdLst>
   <p:sldIdLst>
-    <p:sldId xmlns:r="http://schemas.openxmlformats.org/officeDocument/2006/relationships" id="256" r:id="R496ad683691e4986"/>
-    <p:sldId xmlns:r="http://schemas.openxmlformats.org/officeDocument/2006/relationships" id="257" r:id="R693afe4a8f7a4683"/>
-    <p:sldId xmlns:r="http://schemas.openxmlformats.org/officeDocument/2006/relationships" id="258" r:id="Racca87e7fdc74763"/>
-    <p:sldId xmlns:r="http://schemas.openxmlformats.org/officeDocument/2006/relationships" id="259" r:id="R3eacd5acfbde41a6"/>
-    <p:sldId xmlns:r="http://schemas.openxmlformats.org/officeDocument/2006/relationships" id="260" r:id="R70286b0a17cf4e49"/>
-    <p:sldId xmlns:r="http://schemas.openxmlformats.org/officeDocument/2006/relationships" id="261" r:id="Rf1cc7768d1064aa0"/>
-    <p:sldId xmlns:r="http://schemas.openxmlformats.org/officeDocument/2006/relationships" id="262" r:id="R94ca55d5f60f4721"/>
-    <p:sldId xmlns:r="http://schemas.openxmlformats.org/officeDocument/2006/relationships" id="263" r:id="Racb57bbbd25340fc"/>
+    <p:sldId xmlns:r="http://schemas.openxmlformats.org/officeDocument/2006/relationships" id="256" r:id="Rc4b8f8d505264f4d"/>
+    <p:sldId xmlns:r="http://schemas.openxmlformats.org/officeDocument/2006/relationships" id="257" r:id="R0ee5da51d1a6443d"/>
+    <p:sldId xmlns:r="http://schemas.openxmlformats.org/officeDocument/2006/relationships" id="258" r:id="Re601b03834e14e9a"/>
+    <p:sldId xmlns:r="http://schemas.openxmlformats.org/officeDocument/2006/relationships" id="259" r:id="Ra2ecf9d8e0274ea1"/>
+    <p:sldId xmlns:r="http://schemas.openxmlformats.org/officeDocument/2006/relationships" id="260" r:id="Rdb66338da862479f"/>
+    <p:sldId xmlns:r="http://schemas.openxmlformats.org/officeDocument/2006/relationships" id="261" r:id="Rf68a52d6790b4200"/>
+    <p:sldId xmlns:r="http://schemas.openxmlformats.org/officeDocument/2006/relationships" id="262" r:id="Rb5bea29a6e4f4e0f"/>
+    <p:sldId xmlns:r="http://schemas.openxmlformats.org/officeDocument/2006/relationships" id="263" r:id="Rb28b3f6a7dce41a9"/>
   </p:sldIdLst>
   <p:sldSz cx="12191695" cy="6858000"/>
   <p:notesSz cx="6858000" cy="9144000"/>
@@ -1055,7 +1055,7 @@
   </p:cSld>
   <p:clrMap bg1="lt1" tx1="dk1" bg2="lt2" tx2="dk2" accent1="accent1" accent2="accent2" accent3="accent3" accent4="accent4" accent5="accent5" accent6="accent6" hlink="hlink" folHlink="folHlink"/>
   <p:sldLayoutIdLst>
-    <p:sldLayoutId xmlns:r="http://schemas.openxmlformats.org/officeDocument/2006/relationships" id="2147483649" r:id="Rabb0e795dddf4261"/>
+    <p:sldLayoutId xmlns:r="http://schemas.openxmlformats.org/officeDocument/2006/relationships" id="2147483649" r:id="R863a2437654e42dc"/>
   </p:sldLayoutIdLst>
   <p:hf sldNum="0" hdr="0" ftr="0" dt="0"/>
   <p:txStyles>
@@ -1608,7 +1608,7 @@
     <p:bg>
       <p:bgPr>
         <a:solidFill xmlns:a="http://schemas.openxmlformats.org/drawingml/2006/main">
-          <a:srgbClr val="0E1118"/>
+          <a:srgbClr val="0B0F12"/>
         </a:solidFill>
       </p:bgPr>
     </p:bg>
@@ -1626,7 +1626,7 @@
           <p:cNvPr id="2" name="Text 0">
             <a:extLst xmlns:a="http://schemas.openxmlformats.org/drawingml/2006/main">
               <a:ext uri="{FF2B5EF4-FFF2-40B4-BE49-F238E27FC236}">
-                <a16:creationId xmlns:a16="http://schemas.microsoft.com/office/drawing/2014/main" id="{1CE42538-3E26-4301-9ADC-CBD3B10B7FB6}"/>
+                <a16:creationId xmlns:a16="http://schemas.microsoft.com/office/drawing/2014/main" id="{53BDDD83-7075-49B4-9696-E27F05827FD1}"/>
               </a:ext>
             </a:extLst>
           </p:cNvPr>
@@ -1655,7 +1655,7 @@
             <a:r>
               <a:rPr sz="4400" b="1">
                 <a:solidFill>
-                  <a:srgbClr val="F5F7FF"/>
+                  <a:srgbClr val="F2F4EE"/>
                 </a:solidFill>
                 <a:latin typeface="Arial"/>
                 <a:ea typeface="Arial"/>
@@ -1672,7 +1672,7 @@
           <p:cNvPr id="3" name="Text 1">
             <a:extLst xmlns:a="http://schemas.openxmlformats.org/drawingml/2006/main">
               <a:ext uri="{FF2B5EF4-FFF2-40B4-BE49-F238E27FC236}">
-                <a16:creationId xmlns:a16="http://schemas.microsoft.com/office/drawing/2014/main" id="{1369EC82-121E-4335-A0A7-5360419AF46A}"/>
+                <a16:creationId xmlns:a16="http://schemas.microsoft.com/office/drawing/2014/main" id="{8A6B7F90-F27D-4820-A817-E30BF0ECCA7A}"/>
               </a:ext>
             </a:extLst>
           </p:cNvPr>
@@ -1701,7 +1701,7 @@
             <a:r>
               <a:rPr sz="2000">
                 <a:solidFill>
-                  <a:srgbClr val="B7C0D3"/>
+                  <a:srgbClr val="9CAAA9"/>
                 </a:solidFill>
                 <a:latin typeface="Arial"/>
                 <a:ea typeface="Arial"/>
@@ -1718,7 +1718,7 @@
           <p:cNvPr id="4" name="Text 2">
             <a:extLst xmlns:a="http://schemas.openxmlformats.org/drawingml/2006/main">
               <a:ext uri="{FF2B5EF4-FFF2-40B4-BE49-F238E27FC236}">
-                <a16:creationId xmlns:a16="http://schemas.microsoft.com/office/drawing/2014/main" id="{1A28A91A-C47E-49A4-BE05-5BD0A466DB9B}"/>
+                <a16:creationId xmlns:a16="http://schemas.microsoft.com/office/drawing/2014/main" id="{67D2ABB7-B407-4FF3-B8BF-9AADBD29C538}"/>
               </a:ext>
             </a:extLst>
           </p:cNvPr>
@@ -1747,7 +1747,7 @@
             <a:r>
               <a:rPr sz="1200">
                 <a:solidFill>
-                  <a:srgbClr val="B7C0D3"/>
+                  <a:srgbClr val="9CAAA9"/>
                 </a:solidFill>
                 <a:latin typeface="Arial"/>
                 <a:ea typeface="Arial"/>
@@ -1762,7 +1762,7 @@
     </p:spTree>
     <p:extLst>
       <p:ext uri="{BB962C8B-B14F-4D97-AF65-F5344CB8AC3E}">
-        <p14:creationId xmlns:p14="http://schemas.microsoft.com/office/powerpoint/2010/main" val="406079955"/>
+        <p14:creationId xmlns:p14="http://schemas.microsoft.com/office/powerpoint/2010/main" val="2025167169"/>
       </p:ext>
     </p:extLst>
   </p:cSld>
@@ -1775,7 +1775,7 @@
     <p:bg>
       <p:bgPr>
         <a:solidFill xmlns:a="http://schemas.openxmlformats.org/drawingml/2006/main">
-          <a:srgbClr val="0E1118"/>
+          <a:srgbClr val="0B0F12"/>
         </a:solidFill>
       </p:bgPr>
     </p:bg>
@@ -1793,7 +1793,7 @@
           <p:cNvPr id="2" name="Shape 0">
             <a:extLst xmlns:a="http://schemas.openxmlformats.org/drawingml/2006/main">
               <a:ext uri="{FF2B5EF4-FFF2-40B4-BE49-F238E27FC236}">
-                <a16:creationId xmlns:a16="http://schemas.microsoft.com/office/drawing/2014/main" id="{32B4C53A-D723-4039-A7E8-17160D3C2AF1}"/>
+                <a16:creationId xmlns:a16="http://schemas.microsoft.com/office/drawing/2014/main" id="{B08DB43F-E53E-4140-AB1B-56F2D66EF94D}"/>
               </a:ext>
             </a:extLst>
           </p:cNvPr>
@@ -1811,7 +1811,7 @@
             <a:avLst/>
           </a:prstGeom>
           <a:solidFill xmlns:a="http://schemas.openxmlformats.org/drawingml/2006/main">
-            <a:srgbClr val="6EA8FE"/>
+            <a:srgbClr val="FFE600"/>
           </a:solidFill>
         </p:spPr>
       </p:sp>
@@ -1820,7 +1820,7 @@
           <p:cNvPr id="3" name="Text 1">
             <a:extLst xmlns:a="http://schemas.openxmlformats.org/drawingml/2006/main">
               <a:ext uri="{FF2B5EF4-FFF2-40B4-BE49-F238E27FC236}">
-                <a16:creationId xmlns:a16="http://schemas.microsoft.com/office/drawing/2014/main" id="{DB0895C5-E0F6-4A7F-BECD-BDB9A37B8CB8}"/>
+                <a16:creationId xmlns:a16="http://schemas.microsoft.com/office/drawing/2014/main" id="{33C7548A-1AB5-49E4-B95B-8519F69FFE88}"/>
               </a:ext>
             </a:extLst>
           </p:cNvPr>
@@ -1838,7 +1838,7 @@
             <a:avLst/>
           </a:prstGeom>
           <a:solidFill xmlns:a="http://schemas.openxmlformats.org/drawingml/2006/main">
-            <a:srgbClr val="6EA8FE"/>
+            <a:srgbClr val="FFE600"/>
           </a:solidFill>
         </p:spPr>
         <p:txBody>
@@ -1851,7 +1851,7 @@
             <a:r>
               <a:rPr sz="1200" b="1">
                 <a:solidFill>
-                  <a:srgbClr val="0E1118"/>
+                  <a:srgbClr val="0B0F12"/>
                 </a:solidFill>
                 <a:latin typeface="Arial"/>
                 <a:ea typeface="Arial"/>
@@ -1868,7 +1868,7 @@
           <p:cNvPr id="4" name="Text 2">
             <a:extLst xmlns:a="http://schemas.openxmlformats.org/drawingml/2006/main">
               <a:ext uri="{FF2B5EF4-FFF2-40B4-BE49-F238E27FC236}">
-                <a16:creationId xmlns:a16="http://schemas.microsoft.com/office/drawing/2014/main" id="{7603C69B-1A6E-4D2C-B570-08CFFF5CCF7A}"/>
+                <a16:creationId xmlns:a16="http://schemas.microsoft.com/office/drawing/2014/main" id="{D3AD203A-C9CC-4E57-A1AB-8866DF5D669F}"/>
               </a:ext>
             </a:extLst>
           </p:cNvPr>
@@ -1897,7 +1897,7 @@
             <a:r>
               <a:rPr sz="3000" b="1">
                 <a:solidFill>
-                  <a:srgbClr val="F5F7FF"/>
+                  <a:srgbClr val="F2F4EE"/>
                 </a:solidFill>
                 <a:latin typeface="Arial"/>
                 <a:ea typeface="Arial"/>
@@ -1914,7 +1914,7 @@
           <p:cNvPr id="5" name="Text 3">
             <a:extLst xmlns:a="http://schemas.openxmlformats.org/drawingml/2006/main">
               <a:ext uri="{FF2B5EF4-FFF2-40B4-BE49-F238E27FC236}">
-                <a16:creationId xmlns:a16="http://schemas.microsoft.com/office/drawing/2014/main" id="{E5DFD88A-EEFE-4414-98C4-7678FF586394}"/>
+                <a16:creationId xmlns:a16="http://schemas.microsoft.com/office/drawing/2014/main" id="{D68D3BA2-7C89-4682-83FD-232A0802FFFE}"/>
               </a:ext>
             </a:extLst>
           </p:cNvPr>
@@ -1943,7 +1943,7 @@
             <a:r>
               <a:rPr sz="1800">
                 <a:solidFill>
-                  <a:srgbClr val="B7C0D3"/>
+                  <a:srgbClr val="9CAAA9"/>
                 </a:solidFill>
                 <a:latin typeface="Arial"/>
                 <a:ea typeface="Arial"/>
@@ -1958,7 +1958,7 @@
     </p:spTree>
     <p:extLst>
       <p:ext uri="{BB962C8B-B14F-4D97-AF65-F5344CB8AC3E}">
-        <p14:creationId xmlns:p14="http://schemas.microsoft.com/office/powerpoint/2010/main" val="1674572404"/>
+        <p14:creationId xmlns:p14="http://schemas.microsoft.com/office/powerpoint/2010/main" val="430236318"/>
       </p:ext>
     </p:extLst>
   </p:cSld>
@@ -1971,7 +1971,7 @@
     <p:bg>
       <p:bgPr>
         <a:solidFill xmlns:a="http://schemas.openxmlformats.org/drawingml/2006/main">
-          <a:srgbClr val="0E1118"/>
+          <a:srgbClr val="0B0F12"/>
         </a:solidFill>
       </p:bgPr>
     </p:bg>
@@ -1989,7 +1989,7 @@
           <p:cNvPr id="2" name="Shape 0">
             <a:extLst xmlns:a="http://schemas.openxmlformats.org/drawingml/2006/main">
               <a:ext uri="{FF2B5EF4-FFF2-40B4-BE49-F238E27FC236}">
-                <a16:creationId xmlns:a16="http://schemas.microsoft.com/office/drawing/2014/main" id="{BB63CD03-A489-4626-AE49-1068FB453D0E}"/>
+                <a16:creationId xmlns:a16="http://schemas.microsoft.com/office/drawing/2014/main" id="{1C569127-680E-4154-AA89-DEBB251843C7}"/>
               </a:ext>
             </a:extLst>
           </p:cNvPr>
@@ -2007,7 +2007,7 @@
             <a:avLst/>
           </a:prstGeom>
           <a:solidFill xmlns:a="http://schemas.openxmlformats.org/drawingml/2006/main">
-            <a:srgbClr val="6EA8FE"/>
+            <a:srgbClr val="FFE600"/>
           </a:solidFill>
         </p:spPr>
       </p:sp>
@@ -2016,7 +2016,7 @@
           <p:cNvPr id="3" name="Text 1">
             <a:extLst xmlns:a="http://schemas.openxmlformats.org/drawingml/2006/main">
               <a:ext uri="{FF2B5EF4-FFF2-40B4-BE49-F238E27FC236}">
-                <a16:creationId xmlns:a16="http://schemas.microsoft.com/office/drawing/2014/main" id="{A2141186-1858-4AB8-837A-64D71B61AC51}"/>
+                <a16:creationId xmlns:a16="http://schemas.microsoft.com/office/drawing/2014/main" id="{E4C99A64-A054-4FCC-8442-6817E6379E46}"/>
               </a:ext>
             </a:extLst>
           </p:cNvPr>
@@ -2034,7 +2034,7 @@
             <a:avLst/>
           </a:prstGeom>
           <a:solidFill xmlns:a="http://schemas.openxmlformats.org/drawingml/2006/main">
-            <a:srgbClr val="6EA8FE"/>
+            <a:srgbClr val="FFE600"/>
           </a:solidFill>
         </p:spPr>
         <p:txBody>
@@ -2047,7 +2047,7 @@
             <a:r>
               <a:rPr sz="1200" b="1">
                 <a:solidFill>
-                  <a:srgbClr val="0E1118"/>
+                  <a:srgbClr val="0B0F12"/>
                 </a:solidFill>
                 <a:latin typeface="Arial"/>
                 <a:ea typeface="Arial"/>
@@ -2064,7 +2064,7 @@
           <p:cNvPr id="4" name="Text 2">
             <a:extLst xmlns:a="http://schemas.openxmlformats.org/drawingml/2006/main">
               <a:ext uri="{FF2B5EF4-FFF2-40B4-BE49-F238E27FC236}">
-                <a16:creationId xmlns:a16="http://schemas.microsoft.com/office/drawing/2014/main" id="{947D7544-7BC0-4F84-91D3-1231E4512DD2}"/>
+                <a16:creationId xmlns:a16="http://schemas.microsoft.com/office/drawing/2014/main" id="{015E999F-9FBB-4FC9-A44E-1C3CE0D2777E}"/>
               </a:ext>
             </a:extLst>
           </p:cNvPr>
@@ -2093,7 +2093,7 @@
             <a:r>
               <a:rPr sz="3000" b="1">
                 <a:solidFill>
-                  <a:srgbClr val="F5F7FF"/>
+                  <a:srgbClr val="F2F4EE"/>
                 </a:solidFill>
                 <a:latin typeface="Arial"/>
                 <a:ea typeface="Arial"/>
@@ -2110,7 +2110,7 @@
           <p:cNvPr id="5" name="Text 3">
             <a:extLst xmlns:a="http://schemas.openxmlformats.org/drawingml/2006/main">
               <a:ext uri="{FF2B5EF4-FFF2-40B4-BE49-F238E27FC236}">
-                <a16:creationId xmlns:a16="http://schemas.microsoft.com/office/drawing/2014/main" id="{E3CA81F2-C87E-492A-9D5E-F1C19FED82FF}"/>
+                <a16:creationId xmlns:a16="http://schemas.microsoft.com/office/drawing/2014/main" id="{3F633250-C1C1-4E03-9F78-A2CF546B5647}"/>
               </a:ext>
             </a:extLst>
           </p:cNvPr>
@@ -2139,7 +2139,7 @@
             <a:r>
               <a:rPr sz="1800">
                 <a:solidFill>
-                  <a:srgbClr val="B7C0D3"/>
+                  <a:srgbClr val="9CAAA9"/>
                 </a:solidFill>
                 <a:latin typeface="Arial"/>
                 <a:ea typeface="Arial"/>
@@ -2154,7 +2154,7 @@
     </p:spTree>
     <p:extLst>
       <p:ext uri="{BB962C8B-B14F-4D97-AF65-F5344CB8AC3E}">
-        <p14:creationId xmlns:p14="http://schemas.microsoft.com/office/powerpoint/2010/main" val="1708014394"/>
+        <p14:creationId xmlns:p14="http://schemas.microsoft.com/office/powerpoint/2010/main" val="2035506384"/>
       </p:ext>
     </p:extLst>
   </p:cSld>
@@ -2167,7 +2167,7 @@
     <p:bg>
       <p:bgPr>
         <a:solidFill xmlns:a="http://schemas.openxmlformats.org/drawingml/2006/main">
-          <a:srgbClr val="0E1118"/>
+          <a:srgbClr val="0B0F12"/>
         </a:solidFill>
       </p:bgPr>
     </p:bg>
@@ -2185,7 +2185,7 @@
           <p:cNvPr id="2" name="Shape 0">
             <a:extLst xmlns:a="http://schemas.openxmlformats.org/drawingml/2006/main">
               <a:ext uri="{FF2B5EF4-FFF2-40B4-BE49-F238E27FC236}">
-                <a16:creationId xmlns:a16="http://schemas.microsoft.com/office/drawing/2014/main" id="{705AA2B4-8D4A-458E-B781-029C0DA95980}"/>
+                <a16:creationId xmlns:a16="http://schemas.microsoft.com/office/drawing/2014/main" id="{B31E916C-B5DD-488F-B590-04EA036BF8B6}"/>
               </a:ext>
             </a:extLst>
           </p:cNvPr>
@@ -2203,7 +2203,7 @@
             <a:avLst/>
           </a:prstGeom>
           <a:solidFill xmlns:a="http://schemas.openxmlformats.org/drawingml/2006/main">
-            <a:srgbClr val="6EA8FE"/>
+            <a:srgbClr val="FFE600"/>
           </a:solidFill>
         </p:spPr>
       </p:sp>
@@ -2212,7 +2212,7 @@
           <p:cNvPr id="3" name="Text 1">
             <a:extLst xmlns:a="http://schemas.openxmlformats.org/drawingml/2006/main">
               <a:ext uri="{FF2B5EF4-FFF2-40B4-BE49-F238E27FC236}">
-                <a16:creationId xmlns:a16="http://schemas.microsoft.com/office/drawing/2014/main" id="{52233712-5591-4C04-848D-7F42E8ADB8EC}"/>
+                <a16:creationId xmlns:a16="http://schemas.microsoft.com/office/drawing/2014/main" id="{704F49AB-2302-4370-BACA-C90174E535BF}"/>
               </a:ext>
             </a:extLst>
           </p:cNvPr>
@@ -2230,7 +2230,7 @@
             <a:avLst/>
           </a:prstGeom>
           <a:solidFill xmlns:a="http://schemas.openxmlformats.org/drawingml/2006/main">
-            <a:srgbClr val="6EA8FE"/>
+            <a:srgbClr val="FFE600"/>
           </a:solidFill>
         </p:spPr>
         <p:txBody>
@@ -2243,7 +2243,7 @@
             <a:r>
               <a:rPr sz="1200" b="1">
                 <a:solidFill>
-                  <a:srgbClr val="0E1118"/>
+                  <a:srgbClr val="0B0F12"/>
                 </a:solidFill>
                 <a:latin typeface="Arial"/>
                 <a:ea typeface="Arial"/>
@@ -2260,7 +2260,7 @@
           <p:cNvPr id="4" name="Text 2">
             <a:extLst xmlns:a="http://schemas.openxmlformats.org/drawingml/2006/main">
               <a:ext uri="{FF2B5EF4-FFF2-40B4-BE49-F238E27FC236}">
-                <a16:creationId xmlns:a16="http://schemas.microsoft.com/office/drawing/2014/main" id="{0AE89FC0-DF4E-4F62-8476-14084711AB2F}"/>
+                <a16:creationId xmlns:a16="http://schemas.microsoft.com/office/drawing/2014/main" id="{97471C87-8CDA-4B2C-8C76-0BA868CD5489}"/>
               </a:ext>
             </a:extLst>
           </p:cNvPr>
@@ -2289,7 +2289,7 @@
             <a:r>
               <a:rPr sz="3000" b="1">
                 <a:solidFill>
-                  <a:srgbClr val="F5F7FF"/>
+                  <a:srgbClr val="F2F4EE"/>
                 </a:solidFill>
                 <a:latin typeface="Arial"/>
                 <a:ea typeface="Arial"/>
@@ -2306,7 +2306,7 @@
           <p:cNvPr id="5" name="Text 3">
             <a:extLst xmlns:a="http://schemas.openxmlformats.org/drawingml/2006/main">
               <a:ext uri="{FF2B5EF4-FFF2-40B4-BE49-F238E27FC236}">
-                <a16:creationId xmlns:a16="http://schemas.microsoft.com/office/drawing/2014/main" id="{7C235DDA-2C66-4C06-83CC-C4F9D19E5C15}"/>
+                <a16:creationId xmlns:a16="http://schemas.microsoft.com/office/drawing/2014/main" id="{71A6AAA1-B13D-4E96-94A4-92B70A5B33EE}"/>
               </a:ext>
             </a:extLst>
           </p:cNvPr>
@@ -2335,7 +2335,7 @@
             <a:r>
               <a:rPr sz="1800">
                 <a:solidFill>
-                  <a:srgbClr val="B7C0D3"/>
+                  <a:srgbClr val="9CAAA9"/>
                 </a:solidFill>
                 <a:latin typeface="Arial"/>
                 <a:ea typeface="Arial"/>
@@ -2350,7 +2350,7 @@
     </p:spTree>
     <p:extLst>
       <p:ext uri="{BB962C8B-B14F-4D97-AF65-F5344CB8AC3E}">
-        <p14:creationId xmlns:p14="http://schemas.microsoft.com/office/powerpoint/2010/main" val="1589907620"/>
+        <p14:creationId xmlns:p14="http://schemas.microsoft.com/office/powerpoint/2010/main" val="549096802"/>
       </p:ext>
     </p:extLst>
   </p:cSld>
@@ -2363,7 +2363,7 @@
     <p:bg>
       <p:bgPr>
         <a:solidFill xmlns:a="http://schemas.openxmlformats.org/drawingml/2006/main">
-          <a:srgbClr val="0E1118"/>
+          <a:srgbClr val="0B0F12"/>
         </a:solidFill>
       </p:bgPr>
     </p:bg>
@@ -2381,7 +2381,7 @@
           <p:cNvPr id="2" name="Shape 0">
             <a:extLst xmlns:a="http://schemas.openxmlformats.org/drawingml/2006/main">
               <a:ext uri="{FF2B5EF4-FFF2-40B4-BE49-F238E27FC236}">
-                <a16:creationId xmlns:a16="http://schemas.microsoft.com/office/drawing/2014/main" id="{23BF6118-DD4E-4A38-BAEA-178193CD133B}"/>
+                <a16:creationId xmlns:a16="http://schemas.microsoft.com/office/drawing/2014/main" id="{D1C288F7-28BD-472F-8C87-F1CB8FD5C6DE}"/>
               </a:ext>
             </a:extLst>
           </p:cNvPr>
@@ -2399,7 +2399,7 @@
             <a:avLst/>
           </a:prstGeom>
           <a:solidFill xmlns:a="http://schemas.openxmlformats.org/drawingml/2006/main">
-            <a:srgbClr val="6EA8FE"/>
+            <a:srgbClr val="FFE600"/>
           </a:solidFill>
         </p:spPr>
       </p:sp>
@@ -2408,7 +2408,7 @@
           <p:cNvPr id="3" name="Text 1">
             <a:extLst xmlns:a="http://schemas.openxmlformats.org/drawingml/2006/main">
               <a:ext uri="{FF2B5EF4-FFF2-40B4-BE49-F238E27FC236}">
-                <a16:creationId xmlns:a16="http://schemas.microsoft.com/office/drawing/2014/main" id="{71561734-146B-47D2-963D-EEF126D8FA90}"/>
+                <a16:creationId xmlns:a16="http://schemas.microsoft.com/office/drawing/2014/main" id="{91F08142-9E25-4710-B484-A686815DAE0D}"/>
               </a:ext>
             </a:extLst>
           </p:cNvPr>
@@ -2426,7 +2426,7 @@
             <a:avLst/>
           </a:prstGeom>
           <a:solidFill xmlns:a="http://schemas.openxmlformats.org/drawingml/2006/main">
-            <a:srgbClr val="6EA8FE"/>
+            <a:srgbClr val="FFE600"/>
           </a:solidFill>
         </p:spPr>
         <p:txBody>
@@ -2439,7 +2439,7 @@
             <a:r>
               <a:rPr sz="1200" b="1">
                 <a:solidFill>
-                  <a:srgbClr val="0E1118"/>
+                  <a:srgbClr val="0B0F12"/>
                 </a:solidFill>
                 <a:latin typeface="Arial"/>
                 <a:ea typeface="Arial"/>
@@ -2456,7 +2456,7 @@
           <p:cNvPr id="4" name="Text 2">
             <a:extLst xmlns:a="http://schemas.openxmlformats.org/drawingml/2006/main">
               <a:ext uri="{FF2B5EF4-FFF2-40B4-BE49-F238E27FC236}">
-                <a16:creationId xmlns:a16="http://schemas.microsoft.com/office/drawing/2014/main" id="{E0D9027D-19D6-4058-9A4D-006525E5EF4D}"/>
+                <a16:creationId xmlns:a16="http://schemas.microsoft.com/office/drawing/2014/main" id="{82B808B3-78A0-494C-AF02-FDC714887199}"/>
               </a:ext>
             </a:extLst>
           </p:cNvPr>
@@ -2485,7 +2485,7 @@
             <a:r>
               <a:rPr sz="3000" b="1">
                 <a:solidFill>
-                  <a:srgbClr val="F5F7FF"/>
+                  <a:srgbClr val="F2F4EE"/>
                 </a:solidFill>
                 <a:latin typeface="Arial"/>
                 <a:ea typeface="Arial"/>
@@ -2502,7 +2502,7 @@
           <p:cNvPr id="5" name="Text 3">
             <a:extLst xmlns:a="http://schemas.openxmlformats.org/drawingml/2006/main">
               <a:ext uri="{FF2B5EF4-FFF2-40B4-BE49-F238E27FC236}">
-                <a16:creationId xmlns:a16="http://schemas.microsoft.com/office/drawing/2014/main" id="{71C09A78-81CD-43CE-A1CD-80C1BE51B4CB}"/>
+                <a16:creationId xmlns:a16="http://schemas.microsoft.com/office/drawing/2014/main" id="{B609BF40-D1C9-4218-B49B-F7B3416CB479}"/>
               </a:ext>
             </a:extLst>
           </p:cNvPr>
@@ -2531,7 +2531,7 @@
             <a:r>
               <a:rPr sz="1800">
                 <a:solidFill>
-                  <a:srgbClr val="B7C0D3"/>
+                  <a:srgbClr val="9CAAA9"/>
                 </a:solidFill>
                 <a:latin typeface="Arial"/>
                 <a:ea typeface="Arial"/>
@@ -2546,7 +2546,7 @@
     </p:spTree>
     <p:extLst>
       <p:ext uri="{BB962C8B-B14F-4D97-AF65-F5344CB8AC3E}">
-        <p14:creationId xmlns:p14="http://schemas.microsoft.com/office/powerpoint/2010/main" val="743675027"/>
+        <p14:creationId xmlns:p14="http://schemas.microsoft.com/office/powerpoint/2010/main" val="56706615"/>
       </p:ext>
     </p:extLst>
   </p:cSld>
@@ -2559,7 +2559,7 @@
     <p:bg>
       <p:bgPr>
         <a:solidFill xmlns:a="http://schemas.openxmlformats.org/drawingml/2006/main">
-          <a:srgbClr val="0E1118"/>
+          <a:srgbClr val="0B0F12"/>
         </a:solidFill>
       </p:bgPr>
     </p:bg>
@@ -2577,7 +2577,7 @@
           <p:cNvPr id="2" name="Shape 0">
             <a:extLst xmlns:a="http://schemas.openxmlformats.org/drawingml/2006/main">
               <a:ext uri="{FF2B5EF4-FFF2-40B4-BE49-F238E27FC236}">
-                <a16:creationId xmlns:a16="http://schemas.microsoft.com/office/drawing/2014/main" id="{C616758C-0115-47EB-A368-AE02360ED1D5}"/>
+                <a16:creationId xmlns:a16="http://schemas.microsoft.com/office/drawing/2014/main" id="{7CE593A3-9134-4E69-93B7-DC56F4AE254D}"/>
               </a:ext>
             </a:extLst>
           </p:cNvPr>
@@ -2595,7 +2595,7 @@
             <a:avLst/>
           </a:prstGeom>
           <a:solidFill xmlns:a="http://schemas.openxmlformats.org/drawingml/2006/main">
-            <a:srgbClr val="6EA8FE"/>
+            <a:srgbClr val="FFE600"/>
           </a:solidFill>
         </p:spPr>
       </p:sp>
@@ -2604,7 +2604,7 @@
           <p:cNvPr id="3" name="Text 1">
             <a:extLst xmlns:a="http://schemas.openxmlformats.org/drawingml/2006/main">
               <a:ext uri="{FF2B5EF4-FFF2-40B4-BE49-F238E27FC236}">
-                <a16:creationId xmlns:a16="http://schemas.microsoft.com/office/drawing/2014/main" id="{C2722AA8-8D0E-4AC2-A33D-0CFE248F06F6}"/>
+                <a16:creationId xmlns:a16="http://schemas.microsoft.com/office/drawing/2014/main" id="{412C6A8E-092F-4F74-BD6F-C4BCF11B3FF4}"/>
               </a:ext>
             </a:extLst>
           </p:cNvPr>
@@ -2622,7 +2622,7 @@
             <a:avLst/>
           </a:prstGeom>
           <a:solidFill xmlns:a="http://schemas.openxmlformats.org/drawingml/2006/main">
-            <a:srgbClr val="6EA8FE"/>
+            <a:srgbClr val="FFE600"/>
           </a:solidFill>
         </p:spPr>
         <p:txBody>
@@ -2635,7 +2635,7 @@
             <a:r>
               <a:rPr sz="1200" b="1">
                 <a:solidFill>
-                  <a:srgbClr val="0E1118"/>
+                  <a:srgbClr val="0B0F12"/>
                 </a:solidFill>
                 <a:latin typeface="Arial"/>
                 <a:ea typeface="Arial"/>
@@ -2652,7 +2652,7 @@
           <p:cNvPr id="4" name="Text 2">
             <a:extLst xmlns:a="http://schemas.openxmlformats.org/drawingml/2006/main">
               <a:ext uri="{FF2B5EF4-FFF2-40B4-BE49-F238E27FC236}">
-                <a16:creationId xmlns:a16="http://schemas.microsoft.com/office/drawing/2014/main" id="{389B464C-38CD-4980-9406-F6DC639D4D6C}"/>
+                <a16:creationId xmlns:a16="http://schemas.microsoft.com/office/drawing/2014/main" id="{DC35B71D-64C7-4693-A1AF-41C964533697}"/>
               </a:ext>
             </a:extLst>
           </p:cNvPr>
@@ -2681,7 +2681,7 @@
             <a:r>
               <a:rPr sz="3000" b="1">
                 <a:solidFill>
-                  <a:srgbClr val="F5F7FF"/>
+                  <a:srgbClr val="F2F4EE"/>
                 </a:solidFill>
                 <a:latin typeface="Arial"/>
                 <a:ea typeface="Arial"/>
@@ -2698,7 +2698,7 @@
           <p:cNvPr id="5" name="Text 3">
             <a:extLst xmlns:a="http://schemas.openxmlformats.org/drawingml/2006/main">
               <a:ext uri="{FF2B5EF4-FFF2-40B4-BE49-F238E27FC236}">
-                <a16:creationId xmlns:a16="http://schemas.microsoft.com/office/drawing/2014/main" id="{96494270-81B6-4BDA-ABB8-E79AB4B31ACF}"/>
+                <a16:creationId xmlns:a16="http://schemas.microsoft.com/office/drawing/2014/main" id="{152E0422-D448-44C4-91A7-AECCA3F02E5D}"/>
               </a:ext>
             </a:extLst>
           </p:cNvPr>
@@ -2727,7 +2727,7 @@
             <a:r>
               <a:rPr sz="1800">
                 <a:solidFill>
-                  <a:srgbClr val="B7C0D3"/>
+                  <a:srgbClr val="9CAAA9"/>
                 </a:solidFill>
                 <a:latin typeface="Arial"/>
                 <a:ea typeface="Arial"/>
@@ -2744,7 +2744,7 @@
           <p:cNvPr id="6" name="Text 4">
             <a:extLst xmlns:a="http://schemas.openxmlformats.org/drawingml/2006/main">
               <a:ext uri="{FF2B5EF4-FFF2-40B4-BE49-F238E27FC236}">
-                <a16:creationId xmlns:a16="http://schemas.microsoft.com/office/drawing/2014/main" id="{0D77382E-1DA3-48E9-B53D-19DAA6950F1D}"/>
+                <a16:creationId xmlns:a16="http://schemas.microsoft.com/office/drawing/2014/main" id="{36632AE4-1B4E-4744-9C82-BB9A7603D34C}"/>
               </a:ext>
             </a:extLst>
           </p:cNvPr>
@@ -2773,7 +2773,7 @@
             <a:r>
               <a:rPr sz="1100">
                 <a:solidFill>
-                  <a:srgbClr val="B7C0D3"/>
+                  <a:srgbClr val="9CAAA9"/>
                 </a:solidFill>
                 <a:latin typeface="Courier New"/>
                 <a:ea typeface="Courier New"/>
@@ -2790,7 +2790,7 @@
             <a:r>
               <a:rPr sz="1100">
                 <a:solidFill>
-                  <a:srgbClr val="B7C0D3"/>
+                  <a:srgbClr val="9CAAA9"/>
                 </a:solidFill>
                 <a:latin typeface="Courier New"/>
                 <a:ea typeface="Courier New"/>
@@ -2807,7 +2807,7 @@
             <a:r>
               <a:rPr sz="1100">
                 <a:solidFill>
-                  <a:srgbClr val="B7C0D3"/>
+                  <a:srgbClr val="9CAAA9"/>
                 </a:solidFill>
                 <a:latin typeface="Courier New"/>
                 <a:ea typeface="Courier New"/>
@@ -2824,7 +2824,7 @@
             <a:r>
               <a:rPr sz="1100">
                 <a:solidFill>
-                  <a:srgbClr val="B7C0D3"/>
+                  <a:srgbClr val="9CAAA9"/>
                 </a:solidFill>
                 <a:latin typeface="Courier New"/>
                 <a:ea typeface="Courier New"/>
@@ -2841,7 +2841,7 @@
             <a:r>
               <a:rPr sz="1100">
                 <a:solidFill>
-                  <a:srgbClr val="B7C0D3"/>
+                  <a:srgbClr val="9CAAA9"/>
                 </a:solidFill>
                 <a:latin typeface="Courier New"/>
                 <a:ea typeface="Courier New"/>
@@ -2858,7 +2858,7 @@
             <a:r>
               <a:rPr sz="1100">
                 <a:solidFill>
-                  <a:srgbClr val="B7C0D3"/>
+                  <a:srgbClr val="9CAAA9"/>
                 </a:solidFill>
                 <a:latin typeface="Courier New"/>
                 <a:ea typeface="Courier New"/>
@@ -2875,7 +2875,7 @@
             <a:r>
               <a:rPr sz="1100">
                 <a:solidFill>
-                  <a:srgbClr val="B7C0D3"/>
+                  <a:srgbClr val="9CAAA9"/>
                 </a:solidFill>
                 <a:latin typeface="Courier New"/>
                 <a:ea typeface="Courier New"/>
@@ -2892,7 +2892,7 @@
             <a:r>
               <a:rPr sz="1100">
                 <a:solidFill>
-                  <a:srgbClr val="B7C0D3"/>
+                  <a:srgbClr val="9CAAA9"/>
                 </a:solidFill>
                 <a:latin typeface="Courier New"/>
                 <a:ea typeface="Courier New"/>
@@ -2907,7 +2907,7 @@
     </p:spTree>
     <p:extLst>
       <p:ext uri="{BB962C8B-B14F-4D97-AF65-F5344CB8AC3E}">
-        <p14:creationId xmlns:p14="http://schemas.microsoft.com/office/powerpoint/2010/main" val="1926248081"/>
+        <p14:creationId xmlns:p14="http://schemas.microsoft.com/office/powerpoint/2010/main" val="676323218"/>
       </p:ext>
     </p:extLst>
   </p:cSld>
@@ -2920,7 +2920,7 @@
     <p:bg>
       <p:bgPr>
         <a:solidFill xmlns:a="http://schemas.openxmlformats.org/drawingml/2006/main">
-          <a:srgbClr val="0E1118"/>
+          <a:srgbClr val="0B0F12"/>
         </a:solidFill>
       </p:bgPr>
     </p:bg>
@@ -2938,7 +2938,7 @@
           <p:cNvPr id="2" name="Shape 0">
             <a:extLst xmlns:a="http://schemas.openxmlformats.org/drawingml/2006/main">
               <a:ext uri="{FF2B5EF4-FFF2-40B4-BE49-F238E27FC236}">
-                <a16:creationId xmlns:a16="http://schemas.microsoft.com/office/drawing/2014/main" id="{EFA90FAD-ACD1-4065-B257-D7EA089E454D}"/>
+                <a16:creationId xmlns:a16="http://schemas.microsoft.com/office/drawing/2014/main" id="{0D73267C-B49B-4BDA-98C4-B52692A7115D}"/>
               </a:ext>
             </a:extLst>
           </p:cNvPr>
@@ -2956,7 +2956,7 @@
             <a:avLst/>
           </a:prstGeom>
           <a:solidFill xmlns:a="http://schemas.openxmlformats.org/drawingml/2006/main">
-            <a:srgbClr val="6EA8FE"/>
+            <a:srgbClr val="FFE600"/>
           </a:solidFill>
         </p:spPr>
       </p:sp>
@@ -2965,7 +2965,7 @@
           <p:cNvPr id="3" name="Text 1">
             <a:extLst xmlns:a="http://schemas.openxmlformats.org/drawingml/2006/main">
               <a:ext uri="{FF2B5EF4-FFF2-40B4-BE49-F238E27FC236}">
-                <a16:creationId xmlns:a16="http://schemas.microsoft.com/office/drawing/2014/main" id="{3D8BB80B-18B5-4E07-99C3-F96FE00E381D}"/>
+                <a16:creationId xmlns:a16="http://schemas.microsoft.com/office/drawing/2014/main" id="{B59066A7-496E-409F-9390-C1BB4E6A5330}"/>
               </a:ext>
             </a:extLst>
           </p:cNvPr>
@@ -2983,7 +2983,7 @@
             <a:avLst/>
           </a:prstGeom>
           <a:solidFill xmlns:a="http://schemas.openxmlformats.org/drawingml/2006/main">
-            <a:srgbClr val="6EA8FE"/>
+            <a:srgbClr val="FFE600"/>
           </a:solidFill>
         </p:spPr>
         <p:txBody>
@@ -2996,7 +2996,7 @@
             <a:r>
               <a:rPr sz="1200" b="1">
                 <a:solidFill>
-                  <a:srgbClr val="0E1118"/>
+                  <a:srgbClr val="0B0F12"/>
                 </a:solidFill>
                 <a:latin typeface="Arial"/>
                 <a:ea typeface="Arial"/>
@@ -3013,7 +3013,7 @@
           <p:cNvPr id="4" name="Text 2">
             <a:extLst xmlns:a="http://schemas.openxmlformats.org/drawingml/2006/main">
               <a:ext uri="{FF2B5EF4-FFF2-40B4-BE49-F238E27FC236}">
-                <a16:creationId xmlns:a16="http://schemas.microsoft.com/office/drawing/2014/main" id="{7C565F2B-098F-450D-BFE3-866D18286A80}"/>
+                <a16:creationId xmlns:a16="http://schemas.microsoft.com/office/drawing/2014/main" id="{BA023237-375C-4137-9A7D-E6176CF2736B}"/>
               </a:ext>
             </a:extLst>
           </p:cNvPr>
@@ -3042,7 +3042,7 @@
             <a:r>
               <a:rPr sz="3000" b="1">
                 <a:solidFill>
-                  <a:srgbClr val="F5F7FF"/>
+                  <a:srgbClr val="F2F4EE"/>
                 </a:solidFill>
                 <a:latin typeface="Arial"/>
                 <a:ea typeface="Arial"/>
@@ -3059,7 +3059,7 @@
           <p:cNvPr id="5" name="Text 3">
             <a:extLst xmlns:a="http://schemas.openxmlformats.org/drawingml/2006/main">
               <a:ext uri="{FF2B5EF4-FFF2-40B4-BE49-F238E27FC236}">
-                <a16:creationId xmlns:a16="http://schemas.microsoft.com/office/drawing/2014/main" id="{66186516-52DA-4B53-B29B-71355F0C170E}"/>
+                <a16:creationId xmlns:a16="http://schemas.microsoft.com/office/drawing/2014/main" id="{B115DE82-5DD0-488C-9258-46D7E80314C3}"/>
               </a:ext>
             </a:extLst>
           </p:cNvPr>
@@ -3088,7 +3088,7 @@
             <a:r>
               <a:rPr sz="1800">
                 <a:solidFill>
-                  <a:srgbClr val="B7C0D3"/>
+                  <a:srgbClr val="9CAAA9"/>
                 </a:solidFill>
                 <a:latin typeface="Arial"/>
                 <a:ea typeface="Arial"/>
@@ -3103,7 +3103,7 @@
     </p:spTree>
     <p:extLst>
       <p:ext uri="{BB962C8B-B14F-4D97-AF65-F5344CB8AC3E}">
-        <p14:creationId xmlns:p14="http://schemas.microsoft.com/office/powerpoint/2010/main" val="1184103423"/>
+        <p14:creationId xmlns:p14="http://schemas.microsoft.com/office/powerpoint/2010/main" val="981069490"/>
       </p:ext>
     </p:extLst>
   </p:cSld>
@@ -3116,7 +3116,7 @@
     <p:bg>
       <p:bgPr>
         <a:solidFill xmlns:a="http://schemas.openxmlformats.org/drawingml/2006/main">
-          <a:srgbClr val="0E1118"/>
+          <a:srgbClr val="0B0F12"/>
         </a:solidFill>
       </p:bgPr>
     </p:bg>
@@ -3134,7 +3134,7 @@
           <p:cNvPr id="2" name="Shape 0">
             <a:extLst xmlns:a="http://schemas.openxmlformats.org/drawingml/2006/main">
               <a:ext uri="{FF2B5EF4-FFF2-40B4-BE49-F238E27FC236}">
-                <a16:creationId xmlns:a16="http://schemas.microsoft.com/office/drawing/2014/main" id="{42BD0ECC-49C7-4342-904D-C94D8FD1537A}"/>
+                <a16:creationId xmlns:a16="http://schemas.microsoft.com/office/drawing/2014/main" id="{F0665730-B986-47F0-B65F-CD0C64B990D8}"/>
               </a:ext>
             </a:extLst>
           </p:cNvPr>
@@ -3152,7 +3152,7 @@
             <a:avLst/>
           </a:prstGeom>
           <a:solidFill xmlns:a="http://schemas.openxmlformats.org/drawingml/2006/main">
-            <a:srgbClr val="6EA8FE"/>
+            <a:srgbClr val="FFE600"/>
           </a:solidFill>
         </p:spPr>
       </p:sp>
@@ -3161,7 +3161,7 @@
           <p:cNvPr id="3" name="Text 1">
             <a:extLst xmlns:a="http://schemas.openxmlformats.org/drawingml/2006/main">
               <a:ext uri="{FF2B5EF4-FFF2-40B4-BE49-F238E27FC236}">
-                <a16:creationId xmlns:a16="http://schemas.microsoft.com/office/drawing/2014/main" id="{1A2FF4D5-1773-41AA-9030-6057EC2E3BBC}"/>
+                <a16:creationId xmlns:a16="http://schemas.microsoft.com/office/drawing/2014/main" id="{5A451ECE-73C5-4541-86A4-78AF01651212}"/>
               </a:ext>
             </a:extLst>
           </p:cNvPr>
@@ -3179,7 +3179,7 @@
             <a:avLst/>
           </a:prstGeom>
           <a:solidFill xmlns:a="http://schemas.openxmlformats.org/drawingml/2006/main">
-            <a:srgbClr val="6EA8FE"/>
+            <a:srgbClr val="FFE600"/>
           </a:solidFill>
         </p:spPr>
         <p:txBody>
@@ -3192,7 +3192,7 @@
             <a:r>
               <a:rPr sz="1200" b="1">
                 <a:solidFill>
-                  <a:srgbClr val="0E1118"/>
+                  <a:srgbClr val="0B0F12"/>
                 </a:solidFill>
                 <a:latin typeface="Arial"/>
                 <a:ea typeface="Arial"/>
@@ -3209,7 +3209,7 @@
           <p:cNvPr id="4" name="Text 2">
             <a:extLst xmlns:a="http://schemas.openxmlformats.org/drawingml/2006/main">
               <a:ext uri="{FF2B5EF4-FFF2-40B4-BE49-F238E27FC236}">
-                <a16:creationId xmlns:a16="http://schemas.microsoft.com/office/drawing/2014/main" id="{0C807095-A26D-434C-9E86-9C2C08EBE36C}"/>
+                <a16:creationId xmlns:a16="http://schemas.microsoft.com/office/drawing/2014/main" id="{8865E109-2291-4A8A-AF32-2234293E771A}"/>
               </a:ext>
             </a:extLst>
           </p:cNvPr>
@@ -3238,7 +3238,7 @@
             <a:r>
               <a:rPr sz="3000" b="1">
                 <a:solidFill>
-                  <a:srgbClr val="F5F7FF"/>
+                  <a:srgbClr val="F2F4EE"/>
                 </a:solidFill>
                 <a:latin typeface="Arial"/>
                 <a:ea typeface="Arial"/>
@@ -3255,7 +3255,7 @@
           <p:cNvPr id="5" name="Text 3">
             <a:extLst xmlns:a="http://schemas.openxmlformats.org/drawingml/2006/main">
               <a:ext uri="{FF2B5EF4-FFF2-40B4-BE49-F238E27FC236}">
-                <a16:creationId xmlns:a16="http://schemas.microsoft.com/office/drawing/2014/main" id="{E82A05A2-9E3D-4C5A-891D-3EFF0BBD2806}"/>
+                <a16:creationId xmlns:a16="http://schemas.microsoft.com/office/drawing/2014/main" id="{4FDF37B2-4161-4AF4-BE14-02340D03833C}"/>
               </a:ext>
             </a:extLst>
           </p:cNvPr>
@@ -3284,7 +3284,7 @@
             <a:r>
               <a:rPr sz="1800">
                 <a:solidFill>
-                  <a:srgbClr val="B7C0D3"/>
+                  <a:srgbClr val="9CAAA9"/>
                 </a:solidFill>
                 <a:latin typeface="Arial"/>
                 <a:ea typeface="Arial"/>
@@ -3299,7 +3299,7 @@
     </p:spTree>
     <p:extLst>
       <p:ext uri="{BB962C8B-B14F-4D97-AF65-F5344CB8AC3E}">
-        <p14:creationId xmlns:p14="http://schemas.microsoft.com/office/powerpoint/2010/main" val="647778198"/>
+        <p14:creationId xmlns:p14="http://schemas.microsoft.com/office/powerpoint/2010/main" val="2063042577"/>
       </p:ext>
     </p:extLst>
   </p:cSld>

</xml_diff>